<commit_message>
Rework expected vs unexpected slide as analyst guidance
Co-Authored-By: Claude Opus 5.5 <noreply@anthropic.com>
Claude-Session: https://claude.ai/code/session_01TchJvgAm7hkcp7ysrLFsP2
</commit_message>
<xml_diff>
--- a/Expected_vs_Unexpected_slide.pptx
+++ b/Expected_vs_Unexpected_slide.pptx
@@ -502,12 +502,26 @@
           <a:p>
             <a:r>
               <a:rPr lang="en-US" dirty="0"/>
-              <a:t>Interactive slide. Read each box and ask the room: is this strange? Take a show of hands, then reveal. The point: whether something is unusual depends on what we expected for this merchant or customer, and the note needs to say both.
-Frequency: not necessarily strange. 13 February is the day before Valentine's Day, so a spike for a florist is expected. That's the kind of external context OSINT can confirm. The note should say what the spike was, what explains it, and the source.
-Velocity: worth investigating. Twelve payouts in five minutes is a sharp change from a few a month. There could be an explanation, such as a platform cap on single payouts splitting one withdrawal into several, as in Case 3. But it needs evidencing, for example by checking pay-ins and the platform's limits.
-Value: strange, unless explained. A £2,500 payment at a café with an £8 average ticket is far outside the expected range. It might be event catering or a large group booking; check the website, the card and the customer's history before concluding.
-Activity patterns: strange. Several things have changed at once: geography, card profile and time of day. Each might be explainable on its own, but together they are a departure from expected activity that needs a clear rationale or escalation.
-Key message: for frequency, velocity, value and activity patterns, always state what was expected, what was seen and why the difference is or isn't a concern.</a:t>
+              <a:t>What "expected vs unexpected" means for an analyst
+Every alert is a question: is this activity what we would expect from this merchant or customer? To answer it, we need two things: a clear picture of what "expected" looks like, and an honest comparison of what we actually see.
+Step 1: Establish the baseline (what is expected). Draw on:
+- The onboarding profile: stated business model, projected volumes, average transaction value, target markets.
+- The merchant's line of business and its peers: what is normal for this type of business?
+- The merchant's or cardholder's own history: how have they behaved over previous months?
+- The wider context: seasonality, promotions, or external events, for example a major sporting event or a public holiday.
+Step 2: Compare across the four dimensions.
+Frequency is how often transactions happen. Look at counts per day, week or month against the baseline. Watch for sudden spikes or drops, and for dormant accounts that suddenly become active. Ask whether it fits how this business trades: a restaurant trades at weekends and evenings, a subscription business monthly.
+Velocity is how quickly activity happens in a short window. Look for many transactions within minutes or hours, funds paid in and quickly paid out, or several cards or attempts in quick succession. High velocity can point to testing, mule activity or layering, but it can also have a legitimate cause such as a platform cap splitting one withdrawal into several payments. Either way, it needs explaining.
+Value is how much is moving. Compare individual amounts to the merchant's average ticket and its peers. Look for large one-off payments, round or repeated amounts, amounts just below a threshold, and cumulative totals against what was projected at onboarding.
+Activity patterns are the overall shape of the activity. Look for new countries, card types or customers, unusual times of day, a high concentration of volume in a few customers, and changes in the mix of pay-ins and payouts. Does the pattern still match the stated business model?
+Step 3: Explain the gap, and evidence it.
+Unexpected does not automatically mean suspicious, and expected does not automatically mean fine. What matters is whether the difference can be explained, and whether that explanation is backed by evidence: pay-in history, OSINT, an RFI response, or the merchant's website.
+Step 4: Write it down.
+For each relevant dimension, the note should say:
+- what we expected, and where that expectation comes from;
+- what we saw, with specific figures;
+- why the difference is, or is not, a concern.
+A note that simply says "activity is in line with expected behaviour" doesn't do this. It tells the reader the conclusion but not how we reached it.</a:t>
             </a:r>
             <a:endParaRPr lang="en-US" dirty="0"/>
           </a:p>
@@ -966,8 +980,8 @@
         </p:nvSpPr>
         <p:spPr>
           <a:xfrm>
-            <a:off x="548640" y="1325880"/>
-            <a:ext cx="1874520" cy="1965960"/>
+            <a:off x="548640" y="1280160"/>
+            <a:ext cx="1874520" cy="2148840"/>
           </a:xfrm>
           <a:prstGeom prst="roundRect">
             <a:avLst>
@@ -993,8 +1007,8 @@
         </p:nvSpPr>
         <p:spPr>
           <a:xfrm>
-            <a:off x="685800" y="1463040"/>
-            <a:ext cx="1600200" cy="1691640"/>
+            <a:off x="667512" y="1399032"/>
+            <a:ext cx="1645920" cy="1920240"/>
           </a:xfrm>
           <a:prstGeom prst="rect">
             <a:avLst/>
@@ -1008,7 +1022,7 @@
           <a:p>
             <a:pPr indent="0" marL="0">
               <a:spcAft>
-                <a:spcPts val="600"/>
+                <a:spcPts val="300"/>
               </a:spcAft>
               <a:buNone/>
             </a:pPr>
@@ -1028,37 +1042,83 @@
           <a:p>
             <a:pPr indent="0" marL="0">
               <a:spcAft>
-                <a:spcPts val="600"/>
+                <a:spcPts val="500"/>
               </a:spcAft>
               <a:buNone/>
             </a:pPr>
             <a:r>
-              <a:rPr lang="en-US" sz="1100" dirty="0">
-                <a:solidFill>
-                  <a:srgbClr val="FFFFFF"/>
-                </a:solidFill>
-                <a:latin typeface="Arial" pitchFamily="34" charset="0"/>
-                <a:ea typeface="Arial" pitchFamily="34" charset="-122"/>
-                <a:cs typeface="Arial" pitchFamily="34" charset="-120"/>
-              </a:rPr>
-              <a:t>Expected: online florist, around 20 transactions a day.</a:t>
-            </a:r>
-            <a:endParaRPr lang="en-US" sz="1400" dirty="0"/>
-          </a:p>
-          <a:p>
-            <a:pPr indent="0" marL="0">
-              <a:buNone/>
-            </a:pPr>
-            <a:r>
-              <a:rPr lang="en-US" sz="1100" b="1" dirty="0">
-                <a:solidFill>
-                  <a:srgbClr val="FFFFFF"/>
-                </a:solidFill>
-                <a:latin typeface="Arial" pitchFamily="34" charset="0"/>
-                <a:ea typeface="Arial" pitchFamily="34" charset="-122"/>
-                <a:cs typeface="Arial" pitchFamily="34" charset="-120"/>
-              </a:rPr>
-              <a:t>Seen: 200 transactions on 13 February.</a:t>
+              <a:rPr lang="en-US" sz="1050" i="1" dirty="0">
+                <a:solidFill>
+                  <a:srgbClr val="FFFFFF"/>
+                </a:solidFill>
+                <a:latin typeface="Arial" pitchFamily="34" charset="0"/>
+                <a:ea typeface="Arial" pitchFamily="34" charset="-122"/>
+                <a:cs typeface="Arial" pitchFamily="34" charset="-120"/>
+              </a:rPr>
+              <a:t>How often transactions happen</a:t>
+            </a:r>
+            <a:endParaRPr lang="en-US" sz="1400" dirty="0"/>
+          </a:p>
+          <a:p>
+            <a:pPr marL="127000" indent="-127000">
+              <a:spcAft>
+                <a:spcPts val="300"/>
+              </a:spcAft>
+              <a:buSzPct val="100000"/>
+              <a:buChar char="•"/>
+            </a:pPr>
+            <a:r>
+              <a:rPr lang="en-US" sz="1050" dirty="0">
+                <a:solidFill>
+                  <a:srgbClr val="FFFFFF"/>
+                </a:solidFill>
+                <a:latin typeface="Arial" pitchFamily="34" charset="0"/>
+                <a:ea typeface="Arial" pitchFamily="34" charset="-122"/>
+                <a:cs typeface="Arial" pitchFamily="34" charset="-120"/>
+              </a:rPr>
+              <a:t>Daily, weekly or monthly counts vs the baseline</a:t>
+            </a:r>
+            <a:endParaRPr lang="en-US" sz="1400" dirty="0"/>
+          </a:p>
+          <a:p>
+            <a:pPr marL="127000" indent="-127000">
+              <a:spcAft>
+                <a:spcPts val="300"/>
+              </a:spcAft>
+              <a:buSzPct val="100000"/>
+              <a:buChar char="•"/>
+            </a:pPr>
+            <a:r>
+              <a:rPr lang="en-US" sz="1050" dirty="0">
+                <a:solidFill>
+                  <a:srgbClr val="FFFFFF"/>
+                </a:solidFill>
+                <a:latin typeface="Arial" pitchFamily="34" charset="0"/>
+                <a:ea typeface="Arial" pitchFamily="34" charset="-122"/>
+                <a:cs typeface="Arial" pitchFamily="34" charset="-120"/>
+              </a:rPr>
+              <a:t>Sudden spikes, drops, or dormancy then activity</a:t>
+            </a:r>
+            <a:endParaRPr lang="en-US" sz="1400" dirty="0"/>
+          </a:p>
+          <a:p>
+            <a:pPr marL="127000" indent="-127000">
+              <a:spcAft>
+                <a:spcPts val="300"/>
+              </a:spcAft>
+              <a:buSzPct val="100000"/>
+              <a:buChar char="•"/>
+            </a:pPr>
+            <a:r>
+              <a:rPr lang="en-US" sz="1050" dirty="0">
+                <a:solidFill>
+                  <a:srgbClr val="FFFFFF"/>
+                </a:solidFill>
+                <a:latin typeface="Arial" pitchFamily="34" charset="0"/>
+                <a:ea typeface="Arial" pitchFamily="34" charset="-122"/>
+                <a:cs typeface="Arial" pitchFamily="34" charset="-120"/>
+              </a:rPr>
+              <a:t>Fits the merchant's trading pattern?</a:t>
             </a:r>
             <a:endParaRPr lang="en-US" sz="1400" dirty="0"/>
           </a:p>
@@ -1072,8 +1132,8 @@
         </p:nvSpPr>
         <p:spPr>
           <a:xfrm>
-            <a:off x="2606040" y="2697480"/>
-            <a:ext cx="1874520" cy="1965960"/>
+            <a:off x="2606040" y="2560320"/>
+            <a:ext cx="1874520" cy="2148840"/>
           </a:xfrm>
           <a:prstGeom prst="roundRect">
             <a:avLst>
@@ -1099,8 +1159,8 @@
         </p:nvSpPr>
         <p:spPr>
           <a:xfrm>
-            <a:off x="2743200" y="2834640"/>
-            <a:ext cx="1600200" cy="1691640"/>
+            <a:off x="2724912" y="2679192"/>
+            <a:ext cx="1645920" cy="1920240"/>
           </a:xfrm>
           <a:prstGeom prst="rect">
             <a:avLst/>
@@ -1114,7 +1174,7 @@
           <a:p>
             <a:pPr indent="0" marL="0">
               <a:spcAft>
-                <a:spcPts val="600"/>
+                <a:spcPts val="300"/>
               </a:spcAft>
               <a:buNone/>
             </a:pPr>
@@ -1134,37 +1194,83 @@
           <a:p>
             <a:pPr indent="0" marL="0">
               <a:spcAft>
-                <a:spcPts val="600"/>
+                <a:spcPts val="500"/>
               </a:spcAft>
               <a:buNone/>
             </a:pPr>
             <a:r>
-              <a:rPr lang="en-US" sz="1100" dirty="0">
-                <a:solidFill>
-                  <a:srgbClr val="FFFFFF"/>
-                </a:solidFill>
-                <a:latin typeface="Arial" pitchFamily="34" charset="0"/>
-                <a:ea typeface="Arial" pitchFamily="34" charset="-122"/>
-                <a:cs typeface="Arial" pitchFamily="34" charset="-120"/>
-              </a:rPr>
-              <a:t>Expected: cardholder withdraws a few times a month.</a:t>
-            </a:r>
-            <a:endParaRPr lang="en-US" sz="1400" dirty="0"/>
-          </a:p>
-          <a:p>
-            <a:pPr indent="0" marL="0">
-              <a:buNone/>
-            </a:pPr>
-            <a:r>
-              <a:rPr lang="en-US" sz="1100" b="1" dirty="0">
-                <a:solidFill>
-                  <a:srgbClr val="FFFFFF"/>
-                </a:solidFill>
-                <a:latin typeface="Arial" pitchFamily="34" charset="0"/>
-                <a:ea typeface="Arial" pitchFamily="34" charset="-122"/>
-                <a:cs typeface="Arial" pitchFamily="34" charset="-120"/>
-              </a:rPr>
-              <a:t>Seen: 12 payouts to one card within 5 minutes.</a:t>
+              <a:rPr lang="en-US" sz="1050" i="1" dirty="0">
+                <a:solidFill>
+                  <a:srgbClr val="FFFFFF"/>
+                </a:solidFill>
+                <a:latin typeface="Arial" pitchFamily="34" charset="0"/>
+                <a:ea typeface="Arial" pitchFamily="34" charset="-122"/>
+                <a:cs typeface="Arial" pitchFamily="34" charset="-120"/>
+              </a:rPr>
+              <a:t>How quickly activity happens in a short window</a:t>
+            </a:r>
+            <a:endParaRPr lang="en-US" sz="1400" dirty="0"/>
+          </a:p>
+          <a:p>
+            <a:pPr marL="127000" indent="-127000">
+              <a:spcAft>
+                <a:spcPts val="300"/>
+              </a:spcAft>
+              <a:buSzPct val="100000"/>
+              <a:buChar char="•"/>
+            </a:pPr>
+            <a:r>
+              <a:rPr lang="en-US" sz="1050" dirty="0">
+                <a:solidFill>
+                  <a:srgbClr val="FFFFFF"/>
+                </a:solidFill>
+                <a:latin typeface="Arial" pitchFamily="34" charset="0"/>
+                <a:ea typeface="Arial" pitchFamily="34" charset="-122"/>
+                <a:cs typeface="Arial" pitchFamily="34" charset="-120"/>
+              </a:rPr>
+              <a:t>Many transactions within minutes or hours</a:t>
+            </a:r>
+            <a:endParaRPr lang="en-US" sz="1400" dirty="0"/>
+          </a:p>
+          <a:p>
+            <a:pPr marL="127000" indent="-127000">
+              <a:spcAft>
+                <a:spcPts val="300"/>
+              </a:spcAft>
+              <a:buSzPct val="100000"/>
+              <a:buChar char="•"/>
+            </a:pPr>
+            <a:r>
+              <a:rPr lang="en-US" sz="1050" dirty="0">
+                <a:solidFill>
+                  <a:srgbClr val="FFFFFF"/>
+                </a:solidFill>
+                <a:latin typeface="Arial" pitchFamily="34" charset="0"/>
+                <a:ea typeface="Arial" pitchFamily="34" charset="-122"/>
+                <a:cs typeface="Arial" pitchFamily="34" charset="-120"/>
+              </a:rPr>
+              <a:t>Rapid pay-in followed by payout</a:t>
+            </a:r>
+            <a:endParaRPr lang="en-US" sz="1400" dirty="0"/>
+          </a:p>
+          <a:p>
+            <a:pPr marL="127000" indent="-127000">
+              <a:spcAft>
+                <a:spcPts val="300"/>
+              </a:spcAft>
+              <a:buSzPct val="100000"/>
+              <a:buChar char="•"/>
+            </a:pPr>
+            <a:r>
+              <a:rPr lang="en-US" sz="1050" dirty="0">
+                <a:solidFill>
+                  <a:srgbClr val="FFFFFF"/>
+                </a:solidFill>
+                <a:latin typeface="Arial" pitchFamily="34" charset="0"/>
+                <a:ea typeface="Arial" pitchFamily="34" charset="-122"/>
+                <a:cs typeface="Arial" pitchFamily="34" charset="-120"/>
+              </a:rPr>
+              <a:t>Several cards or attempts in quick succession</a:t>
             </a:r>
             <a:endParaRPr lang="en-US" sz="1400" dirty="0"/>
           </a:p>
@@ -1178,8 +1284,8 @@
         </p:nvSpPr>
         <p:spPr>
           <a:xfrm>
-            <a:off x="4663440" y="1234440"/>
-            <a:ext cx="1874520" cy="1965960"/>
+            <a:off x="4663440" y="1188720"/>
+            <a:ext cx="1874520" cy="2148840"/>
           </a:xfrm>
           <a:prstGeom prst="roundRect">
             <a:avLst>
@@ -1205,8 +1311,8 @@
         </p:nvSpPr>
         <p:spPr>
           <a:xfrm>
-            <a:off x="4800600" y="1371600"/>
-            <a:ext cx="1600200" cy="1691640"/>
+            <a:off x="4782312" y="1307592"/>
+            <a:ext cx="1645920" cy="1920240"/>
           </a:xfrm>
           <a:prstGeom prst="rect">
             <a:avLst/>
@@ -1220,7 +1326,7 @@
           <a:p>
             <a:pPr indent="0" marL="0">
               <a:spcAft>
-                <a:spcPts val="600"/>
+                <a:spcPts val="300"/>
               </a:spcAft>
               <a:buNone/>
             </a:pPr>
@@ -1240,37 +1346,83 @@
           <a:p>
             <a:pPr indent="0" marL="0">
               <a:spcAft>
-                <a:spcPts val="600"/>
+                <a:spcPts val="500"/>
               </a:spcAft>
               <a:buNone/>
             </a:pPr>
             <a:r>
-              <a:rPr lang="en-US" sz="1100" dirty="0">
-                <a:solidFill>
-                  <a:srgbClr val="FFFFFF"/>
-                </a:solidFill>
-                <a:latin typeface="Arial" pitchFamily="34" charset="0"/>
-                <a:ea typeface="Arial" pitchFamily="34" charset="-122"/>
-                <a:cs typeface="Arial" pitchFamily="34" charset="-120"/>
-              </a:rPr>
-              <a:t>Expected: café with an average ticket of £8.</a:t>
-            </a:r>
-            <a:endParaRPr lang="en-US" sz="1400" dirty="0"/>
-          </a:p>
-          <a:p>
-            <a:pPr indent="0" marL="0">
-              <a:buNone/>
-            </a:pPr>
-            <a:r>
-              <a:rPr lang="en-US" sz="1100" b="1" dirty="0">
-                <a:solidFill>
-                  <a:srgbClr val="FFFFFF"/>
-                </a:solidFill>
-                <a:latin typeface="Arial" pitchFamily="34" charset="0"/>
-                <a:ea typeface="Arial" pitchFamily="34" charset="-122"/>
-                <a:cs typeface="Arial" pitchFamily="34" charset="-120"/>
-              </a:rPr>
-              <a:t>Seen: a single £2,500 payment.</a:t>
+              <a:rPr lang="en-US" sz="1050" i="1" dirty="0">
+                <a:solidFill>
+                  <a:srgbClr val="FFFFFF"/>
+                </a:solidFill>
+                <a:latin typeface="Arial" pitchFamily="34" charset="0"/>
+                <a:ea typeface="Arial" pitchFamily="34" charset="-122"/>
+                <a:cs typeface="Arial" pitchFamily="34" charset="-120"/>
+              </a:rPr>
+              <a:t>How much is moving</a:t>
+            </a:r>
+            <a:endParaRPr lang="en-US" sz="1400" dirty="0"/>
+          </a:p>
+          <a:p>
+            <a:pPr marL="127000" indent="-127000">
+              <a:spcAft>
+                <a:spcPts val="300"/>
+              </a:spcAft>
+              <a:buSzPct val="100000"/>
+              <a:buChar char="•"/>
+            </a:pPr>
+            <a:r>
+              <a:rPr lang="en-US" sz="1050" dirty="0">
+                <a:solidFill>
+                  <a:srgbClr val="FFFFFF"/>
+                </a:solidFill>
+                <a:latin typeface="Arial" pitchFamily="34" charset="0"/>
+                <a:ea typeface="Arial" pitchFamily="34" charset="-122"/>
+                <a:cs typeface="Arial" pitchFamily="34" charset="-120"/>
+              </a:rPr>
+              <a:t>Amounts vs the average ticket and peers</a:t>
+            </a:r>
+            <a:endParaRPr lang="en-US" sz="1400" dirty="0"/>
+          </a:p>
+          <a:p>
+            <a:pPr marL="127000" indent="-127000">
+              <a:spcAft>
+                <a:spcPts val="300"/>
+              </a:spcAft>
+              <a:buSzPct val="100000"/>
+              <a:buChar char="•"/>
+            </a:pPr>
+            <a:r>
+              <a:rPr lang="en-US" sz="1050" dirty="0">
+                <a:solidFill>
+                  <a:srgbClr val="FFFFFF"/>
+                </a:solidFill>
+                <a:latin typeface="Arial" pitchFamily="34" charset="0"/>
+                <a:ea typeface="Arial" pitchFamily="34" charset="-122"/>
+                <a:cs typeface="Arial" pitchFamily="34" charset="-120"/>
+              </a:rPr>
+              <a:t>Large one-offs, round or repeated amounts</a:t>
+            </a:r>
+            <a:endParaRPr lang="en-US" sz="1400" dirty="0"/>
+          </a:p>
+          <a:p>
+            <a:pPr marL="127000" indent="-127000">
+              <a:spcAft>
+                <a:spcPts val="300"/>
+              </a:spcAft>
+              <a:buSzPct val="100000"/>
+              <a:buChar char="•"/>
+            </a:pPr>
+            <a:r>
+              <a:rPr lang="en-US" sz="1050" dirty="0">
+                <a:solidFill>
+                  <a:srgbClr val="FFFFFF"/>
+                </a:solidFill>
+                <a:latin typeface="Arial" pitchFamily="34" charset="0"/>
+                <a:ea typeface="Arial" pitchFamily="34" charset="-122"/>
+                <a:cs typeface="Arial" pitchFamily="34" charset="-120"/>
+              </a:rPr>
+              <a:t>Totals vs onboarding projections</a:t>
             </a:r>
             <a:endParaRPr lang="en-US" sz="1400" dirty="0"/>
           </a:p>
@@ -1284,8 +1436,8 @@
         </p:nvSpPr>
         <p:spPr>
           <a:xfrm>
-            <a:off x="6720840" y="2011680"/>
-            <a:ext cx="1874520" cy="1965960"/>
+            <a:off x="6720840" y="1920240"/>
+            <a:ext cx="1874520" cy="2148840"/>
           </a:xfrm>
           <a:prstGeom prst="roundRect">
             <a:avLst>
@@ -1311,8 +1463,8 @@
         </p:nvSpPr>
         <p:spPr>
           <a:xfrm>
-            <a:off x="6858000" y="2148840"/>
-            <a:ext cx="1600200" cy="1691640"/>
+            <a:off x="6839712" y="2039112"/>
+            <a:ext cx="1645920" cy="1920240"/>
           </a:xfrm>
           <a:prstGeom prst="rect">
             <a:avLst/>
@@ -1326,7 +1478,7 @@
           <a:p>
             <a:pPr indent="0" marL="0">
               <a:spcAft>
-                <a:spcPts val="600"/>
+                <a:spcPts val="300"/>
               </a:spcAft>
               <a:buNone/>
             </a:pPr>
@@ -1346,37 +1498,83 @@
           <a:p>
             <a:pPr indent="0" marL="0">
               <a:spcAft>
-                <a:spcPts val="600"/>
+                <a:spcPts val="500"/>
               </a:spcAft>
               <a:buNone/>
             </a:pPr>
             <a:r>
-              <a:rPr lang="en-US" sz="1100" dirty="0">
-                <a:solidFill>
-                  <a:srgbClr val="FFFFFF"/>
-                </a:solidFill>
-                <a:latin typeface="Arial" pitchFamily="34" charset="0"/>
-                <a:ea typeface="Arial" pitchFamily="34" charset="-122"/>
-                <a:cs typeface="Arial" pitchFamily="34" charset="-120"/>
-              </a:rPr>
-              <a:t>Expected: UK merchant, UK cards, daytime trading.</a:t>
-            </a:r>
-            <a:endParaRPr lang="en-US" sz="1400" dirty="0"/>
-          </a:p>
-          <a:p>
-            <a:pPr indent="0" marL="0">
-              <a:buNone/>
-            </a:pPr>
-            <a:r>
-              <a:rPr lang="en-US" sz="1100" b="1" dirty="0">
-                <a:solidFill>
-                  <a:srgbClr val="FFFFFF"/>
-                </a:solidFill>
-                <a:latin typeface="Arial" pitchFamily="34" charset="0"/>
-                <a:ea typeface="Arial" pitchFamily="34" charset="-122"/>
-                <a:cs typeface="Arial" pitchFamily="34" charset="-120"/>
-              </a:rPr>
-              <a:t>Seen: 40% of volume on new foreign cards, 2am to 4am.</a:t>
+              <a:rPr lang="en-US" sz="1050" i="1" dirty="0">
+                <a:solidFill>
+                  <a:srgbClr val="FFFFFF"/>
+                </a:solidFill>
+                <a:latin typeface="Arial" pitchFamily="34" charset="0"/>
+                <a:ea typeface="Arial" pitchFamily="34" charset="-122"/>
+                <a:cs typeface="Arial" pitchFamily="34" charset="-120"/>
+              </a:rPr>
+              <a:t>The overall shape of the activity</a:t>
+            </a:r>
+            <a:endParaRPr lang="en-US" sz="1400" dirty="0"/>
+          </a:p>
+          <a:p>
+            <a:pPr marL="127000" indent="-127000">
+              <a:spcAft>
+                <a:spcPts val="300"/>
+              </a:spcAft>
+              <a:buSzPct val="100000"/>
+              <a:buChar char="•"/>
+            </a:pPr>
+            <a:r>
+              <a:rPr lang="en-US" sz="1050" dirty="0">
+                <a:solidFill>
+                  <a:srgbClr val="FFFFFF"/>
+                </a:solidFill>
+                <a:latin typeface="Arial" pitchFamily="34" charset="0"/>
+                <a:ea typeface="Arial" pitchFamily="34" charset="-122"/>
+                <a:cs typeface="Arial" pitchFamily="34" charset="-120"/>
+              </a:rPr>
+              <a:t>New countries, card types or customers</a:t>
+            </a:r>
+            <a:endParaRPr lang="en-US" sz="1400" dirty="0"/>
+          </a:p>
+          <a:p>
+            <a:pPr marL="127000" indent="-127000">
+              <a:spcAft>
+                <a:spcPts val="300"/>
+              </a:spcAft>
+              <a:buSzPct val="100000"/>
+              <a:buChar char="•"/>
+            </a:pPr>
+            <a:r>
+              <a:rPr lang="en-US" sz="1050" dirty="0">
+                <a:solidFill>
+                  <a:srgbClr val="FFFFFF"/>
+                </a:solidFill>
+                <a:latin typeface="Arial" pitchFamily="34" charset="0"/>
+                <a:ea typeface="Arial" pitchFamily="34" charset="-122"/>
+                <a:cs typeface="Arial" pitchFamily="34" charset="-120"/>
+              </a:rPr>
+              <a:t>Unusual times of day</a:t>
+            </a:r>
+            <a:endParaRPr lang="en-US" sz="1400" dirty="0"/>
+          </a:p>
+          <a:p>
+            <a:pPr marL="127000" indent="-127000">
+              <a:spcAft>
+                <a:spcPts val="300"/>
+              </a:spcAft>
+              <a:buSzPct val="100000"/>
+              <a:buChar char="•"/>
+            </a:pPr>
+            <a:r>
+              <a:rPr lang="en-US" sz="1050" dirty="0">
+                <a:solidFill>
+                  <a:srgbClr val="FFFFFF"/>
+                </a:solidFill>
+                <a:latin typeface="Arial" pitchFamily="34" charset="0"/>
+                <a:ea typeface="Arial" pitchFamily="34" charset="-122"/>
+                <a:cs typeface="Arial" pitchFamily="34" charset="-120"/>
+              </a:rPr>
+              <a:t>Concentration in a few customers</a:t>
             </a:r>
             <a:endParaRPr lang="en-US" sz="1400" dirty="0"/>
           </a:p>

</xml_diff>